<commit_message>
docs: deck v2 solution and hook slides
Co-Authored-By: Claude Fable 5.1 <noreply@anthropic.com>
Claude-Session: https://claude.ai/code/session_01CjStCNcmtSU9WNnudUPSMi
</commit_message>
<xml_diff>
--- a/docs/LaunchGate-Pitch-v2.pptx
+++ b/docs/LaunchGate-Pitch-v2.pptx
@@ -3166,7 +3166,7 @@
                   <a:srgbClr val="FFFFFF"/>
                 </a:solidFill>
               </a:rPr>
-              <a:t>Money moves in a second.</a:t>
+              <a:t>Fast for customers. Fast for partners.</a:t>
             </a:r>
             <a:endParaRPr lang="en-US" sz="2800" dirty="0"/>
           </a:p>
@@ -3180,7 +3180,7 @@
                   <a:srgbClr val="FFFFFF"/>
                 </a:solidFill>
               </a:rPr>
-              <a:t>Ideas wait 6 to 8 months.</a:t>
+              <a:t>Slow for its own people.</a:t>
             </a:r>
             <a:endParaRPr lang="en-US" sz="2800" dirty="0"/>
           </a:p>
@@ -3330,7 +3330,7 @@
                   <a:srgbClr val="FFFFFF"/>
                 </a:solidFill>
               </a:rPr>
-              <a:t>to authorize a cardholder's transaction, billions of times a year</a:t>
+              <a:t>For customers: to authorize a transaction, billions of times a year.</a:t>
             </a:r>
             <a:endParaRPr lang="en-US" sz="1200" dirty="0"/>
           </a:p>
@@ -3480,7 +3480,7 @@
                   <a:srgbClr val="FFFFFF"/>
                 </a:solidFill>
               </a:rPr>
-              <a:t>Product Express promise to fintechs: a card program live, status visible to every party</a:t>
+              <a:t>For partners: Product Express promises a fintech a live card program, status visible to every party.</a:t>
             </a:r>
             <a:endParaRPr lang="en-US" sz="1200" dirty="0"/>
           </a:p>
@@ -3630,7 +3630,7 @@
                   <a:srgbClr val="FFFFFF"/>
                 </a:solidFill>
               </a:rPr>
-              <a:t>12 handoffs before an internal team can start building. Reported in Discovery.</a:t>
+              <a:t>For its own engineers: 12 handoffs before a team can start building. Reported in Discovery.</a:t>
             </a:r>
             <a:endParaRPr lang="en-US" sz="1200" dirty="0"/>
           </a:p>
@@ -3727,22 +3727,58 @@
                   <a:srgbClr val="FFFFFF"/>
                 </a:solidFill>
               </a:rPr>
+              <a:t>LaunchGate: one request, governed end to end</a:t>
+            </a:r>
+            <a:endParaRPr lang="en-US" sz="2800" dirty="0"/>
+          </a:p>
+        </p:txBody>
+      </p:sp>
+      <p:sp>
+        <p:nvSpPr>
+          <p:cNvPr id="3" name="Text 1"/>
+          <p:cNvSpPr txBox="1"/>
+          <p:nvPr/>
+        </p:nvSpPr>
+        <p:spPr>
+          <a:xfrm>
+            <a:off x="457200" y="868680"/>
+            <a:ext cx="8229600" cy="320040"/>
+          </a:xfrm>
+          <a:prstGeom prst="rect">
+            <a:avLst/>
+          </a:prstGeom>
+          <a:noFill/>
+          <a:ln/>
+        </p:spPr>
+        <p:txBody>
+          <a:bodyPr wrap="square" lIns="0" tIns="0" rIns="0" bIns="0" rtlCol="0" anchor="ctr"/>
+          <a:lstStyle/>
+          <a:p>
+            <a:pPr indent="0" marL="0">
+              <a:buNone/>
+            </a:pPr>
+            <a:r>
+              <a:rPr lang="en-US" sz="1500" dirty="0">
+                <a:solidFill>
+                  <a:srgbClr val="F79E1B"/>
+                </a:solidFill>
+              </a:rPr>
               <a:t>Agents prepare. Rules decide. People approve.</a:t>
             </a:r>
-            <a:endParaRPr lang="en-US" sz="2800" dirty="0"/>
-          </a:p>
-        </p:txBody>
-      </p:sp>
-      <p:sp>
-        <p:nvSpPr>
-          <p:cNvPr id="3" name="Shape 1"/>
+            <a:endParaRPr lang="en-US" sz="1500" dirty="0"/>
+          </a:p>
+        </p:txBody>
+      </p:sp>
+      <p:sp>
+        <p:nvSpPr>
+          <p:cNvPr id="4" name="Shape 2"/>
           <p:cNvSpPr/>
           <p:nvPr/>
         </p:nvSpPr>
         <p:spPr>
           <a:xfrm>
-            <a:off x="457200" y="1325880"/>
-            <a:ext cx="1554480" cy="2560320"/>
+            <a:off x="457200" y="1371600"/>
+            <a:ext cx="1554480" cy="2240280"/>
           </a:xfrm>
           <a:prstGeom prst="roundRect">
             <a:avLst>
@@ -3764,13 +3800,13 @@
       </p:sp>
       <p:sp>
         <p:nvSpPr>
-          <p:cNvPr id="4" name="Shape 2"/>
+          <p:cNvPr id="5" name="Shape 3"/>
           <p:cNvSpPr/>
           <p:nvPr/>
         </p:nvSpPr>
         <p:spPr>
           <a:xfrm>
-            <a:off x="539496" y="1435608"/>
+            <a:off x="539496" y="1472184"/>
             <a:ext cx="530352" cy="530352"/>
           </a:xfrm>
           <a:prstGeom prst="ellipse">
@@ -3789,7 +3825,7 @@
       </p:sp>
       <p:pic>
         <p:nvPicPr>
-          <p:cNvPr id="5" name="Image 0" descr="preencoded.png">    </p:cNvPr>
+          <p:cNvPr id="6" name="Image 0" descr="preencoded.png">    </p:cNvPr>
           <p:cNvPicPr>
             <a:picLocks noChangeAspect="1"/>
           </p:cNvPicPr>
@@ -3803,7 +3839,7 @@
         </p:blipFill>
         <p:spPr>
           <a:xfrm>
-            <a:off x="640080" y="1536192"/>
+            <a:off x="640080" y="1572768"/>
             <a:ext cx="329184" cy="329184"/>
           </a:xfrm>
           <a:prstGeom prst="rect">
@@ -3813,14 +3849,14 @@
       </p:pic>
       <p:sp>
         <p:nvSpPr>
-          <p:cNvPr id="6" name="Text 3"/>
-          <p:cNvSpPr txBox="1"/>
-          <p:nvPr/>
-        </p:nvSpPr>
-        <p:spPr>
-          <a:xfrm>
-            <a:off x="594360" y="2103120"/>
-            <a:ext cx="1325880" cy="320040"/>
+          <p:cNvPr id="7" name="Text 4"/>
+          <p:cNvSpPr txBox="1"/>
+          <p:nvPr/>
+        </p:nvSpPr>
+        <p:spPr>
+          <a:xfrm>
+            <a:off x="594360" y="2121408"/>
+            <a:ext cx="1325880" cy="292608"/>
           </a:xfrm>
           <a:prstGeom prst="rect">
             <a:avLst/>
@@ -3841,7 +3877,7 @@
                   <a:srgbClr val="FFFFFF"/>
                 </a:solidFill>
               </a:rPr>
-              <a:t>1  Ask once</a:t>
+              <a:t>Ask once</a:t>
             </a:r>
             <a:endParaRPr lang="en-US" sz="1250" dirty="0"/>
           </a:p>
@@ -3849,14 +3885,14 @@
       </p:sp>
       <p:sp>
         <p:nvSpPr>
-          <p:cNvPr id="7" name="Text 4"/>
-          <p:cNvSpPr txBox="1"/>
-          <p:nvPr/>
-        </p:nvSpPr>
-        <p:spPr>
-          <a:xfrm>
-            <a:off x="594360" y="2450592"/>
-            <a:ext cx="1325880" cy="1371600"/>
+          <p:cNvPr id="8" name="Text 5"/>
+          <p:cNvSpPr txBox="1"/>
+          <p:nvPr/>
+        </p:nvSpPr>
+        <p:spPr>
+          <a:xfrm>
+            <a:off x="594360" y="2432304"/>
+            <a:ext cx="1325880" cy="1143000"/>
           </a:xfrm>
           <a:prstGeom prst="rect">
             <a:avLst/>
@@ -3872,27 +3908,63 @@
               <a:buNone/>
             </a:pPr>
             <a:r>
-              <a:rPr lang="en-US" sz="1050" dirty="0">
+              <a:rPr lang="en-US" sz="1000" dirty="0">
                 <a:solidFill>
                   <a:srgbClr val="C9CBD3"/>
                 </a:solidFill>
               </a:rPr>
-              <a:t>A business owner or engineer answers a few plain questions. Secure defaults applied.</a:t>
-            </a:r>
-            <a:endParaRPr lang="en-US" sz="1050" dirty="0"/>
-          </a:p>
-        </p:txBody>
-      </p:sp>
-      <p:sp>
-        <p:nvSpPr>
-          <p:cNvPr id="8" name="Shape 5"/>
+              <a:t>A business owner or engineer answers a few plain questions. Secure defaults are applied automatically.</a:t>
+            </a:r>
+            <a:endParaRPr lang="en-US" sz="1000" dirty="0"/>
+          </a:p>
+        </p:txBody>
+      </p:sp>
+      <p:sp>
+        <p:nvSpPr>
+          <p:cNvPr id="9" name="Text 6"/>
+          <p:cNvSpPr txBox="1"/>
+          <p:nvPr/>
+        </p:nvSpPr>
+        <p:spPr>
+          <a:xfrm>
+            <a:off x="1975104" y="2240280"/>
+            <a:ext cx="228600" cy="365760"/>
+          </a:xfrm>
+          <a:prstGeom prst="rect">
+            <a:avLst/>
+          </a:prstGeom>
+          <a:noFill/>
+          <a:ln/>
+        </p:spPr>
+        <p:txBody>
+          <a:bodyPr wrap="square" lIns="0" tIns="0" rIns="0" bIns="0" rtlCol="0" anchor="ctr"/>
+          <a:lstStyle/>
+          <a:p>
+            <a:pPr algn="ctr" indent="0" marL="0">
+              <a:buNone/>
+            </a:pPr>
+            <a:r>
+              <a:rPr lang="en-US" sz="2200" dirty="0">
+                <a:solidFill>
+                  <a:srgbClr val="F79E1B"/>
+                </a:solidFill>
+              </a:rPr>
+              <a:t>›</a:t>
+            </a:r>
+            <a:endParaRPr lang="en-US" sz="2200" dirty="0"/>
+          </a:p>
+        </p:txBody>
+      </p:sp>
+      <p:sp>
+        <p:nvSpPr>
+          <p:cNvPr id="10" name="Shape 7"/>
           <p:cNvSpPr/>
           <p:nvPr/>
         </p:nvSpPr>
         <p:spPr>
           <a:xfrm>
-            <a:off x="2139696" y="1325880"/>
-            <a:ext cx="1554480" cy="2560320"/>
+            <a:off x="2139696" y="1371600"/>
+            <a:ext cx="1554480" cy="2240280"/>
           </a:xfrm>
           <a:prstGeom prst="roundRect">
             <a:avLst>
@@ -3914,13 +3986,13 @@
       </p:sp>
       <p:sp>
         <p:nvSpPr>
-          <p:cNvPr id="9" name="Shape 6"/>
+          <p:cNvPr id="11" name="Shape 8"/>
           <p:cNvSpPr/>
           <p:nvPr/>
         </p:nvSpPr>
         <p:spPr>
           <a:xfrm>
-            <a:off x="2221992" y="1435608"/>
+            <a:off x="2221992" y="1472184"/>
             <a:ext cx="530352" cy="530352"/>
           </a:xfrm>
           <a:prstGeom prst="ellipse">
@@ -3939,7 +4011,7 @@
       </p:sp>
       <p:pic>
         <p:nvPicPr>
-          <p:cNvPr id="10" name="Image 1" descr="preencoded.png">    </p:cNvPr>
+          <p:cNvPr id="12" name="Image 1" descr="preencoded.png">    </p:cNvPr>
           <p:cNvPicPr>
             <a:picLocks noChangeAspect="1"/>
           </p:cNvPicPr>
@@ -3953,7 +4025,7 @@
         </p:blipFill>
         <p:spPr>
           <a:xfrm>
-            <a:off x="2322576" y="1536192"/>
+            <a:off x="2322576" y="1572768"/>
             <a:ext cx="329184" cy="329184"/>
           </a:xfrm>
           <a:prstGeom prst="rect">
@@ -3963,14 +4035,14 @@
       </p:pic>
       <p:sp>
         <p:nvSpPr>
-          <p:cNvPr id="11" name="Text 7"/>
-          <p:cNvSpPr txBox="1"/>
-          <p:nvPr/>
-        </p:nvSpPr>
-        <p:spPr>
-          <a:xfrm>
-            <a:off x="2276856" y="2103120"/>
-            <a:ext cx="1325880" cy="320040"/>
+          <p:cNvPr id="13" name="Text 9"/>
+          <p:cNvSpPr txBox="1"/>
+          <p:nvPr/>
+        </p:nvSpPr>
+        <p:spPr>
+          <a:xfrm>
+            <a:off x="2276856" y="2121408"/>
+            <a:ext cx="1325880" cy="292608"/>
           </a:xfrm>
           <a:prstGeom prst="rect">
             <a:avLst/>
@@ -3991,7 +4063,7 @@
                   <a:srgbClr val="FFFFFF"/>
                 </a:solidFill>
               </a:rPr>
-              <a:t>2  Rules decide</a:t>
+              <a:t>Rules decide</a:t>
             </a:r>
             <a:endParaRPr lang="en-US" sz="1250" dirty="0"/>
           </a:p>
@@ -3999,14 +4071,14 @@
       </p:sp>
       <p:sp>
         <p:nvSpPr>
-          <p:cNvPr id="12" name="Text 8"/>
-          <p:cNvSpPr txBox="1"/>
-          <p:nvPr/>
-        </p:nvSpPr>
-        <p:spPr>
-          <a:xfrm>
-            <a:off x="2276856" y="2450592"/>
-            <a:ext cx="1325880" cy="1371600"/>
+          <p:cNvPr id="14" name="Text 10"/>
+          <p:cNvSpPr txBox="1"/>
+          <p:nvPr/>
+        </p:nvSpPr>
+        <p:spPr>
+          <a:xfrm>
+            <a:off x="2276856" y="2432304"/>
+            <a:ext cx="1325880" cy="1143000"/>
           </a:xfrm>
           <a:prstGeom prst="rect">
             <a:avLst/>
@@ -4022,27 +4094,63 @@
               <a:buNone/>
             </a:pPr>
             <a:r>
-              <a:rPr lang="en-US" sz="1050" dirty="0">
+              <a:rPr lang="en-US" sz="1000" dirty="0">
                 <a:solidFill>
                   <a:srgbClr val="C9CBD3"/>
                 </a:solidFill>
               </a:rPr>
-              <a:t>A deterministic readiness model scores risk; every rule names the control it cites and the fix.</a:t>
-            </a:r>
-            <a:endParaRPr lang="en-US" sz="1050" dirty="0"/>
-          </a:p>
-        </p:txBody>
-      </p:sp>
-      <p:sp>
-        <p:nvSpPr>
-          <p:cNvPr id="13" name="Shape 9"/>
+              <a:t>A deterministic model scores risk and runs every rule. Each result names the control it cites and the fix.</a:t>
+            </a:r>
+            <a:endParaRPr lang="en-US" sz="1000" dirty="0"/>
+          </a:p>
+        </p:txBody>
+      </p:sp>
+      <p:sp>
+        <p:nvSpPr>
+          <p:cNvPr id="15" name="Text 11"/>
+          <p:cNvSpPr txBox="1"/>
+          <p:nvPr/>
+        </p:nvSpPr>
+        <p:spPr>
+          <a:xfrm>
+            <a:off x="3657600" y="2240280"/>
+            <a:ext cx="228600" cy="365760"/>
+          </a:xfrm>
+          <a:prstGeom prst="rect">
+            <a:avLst/>
+          </a:prstGeom>
+          <a:noFill/>
+          <a:ln/>
+        </p:spPr>
+        <p:txBody>
+          <a:bodyPr wrap="square" lIns="0" tIns="0" rIns="0" bIns="0" rtlCol="0" anchor="ctr"/>
+          <a:lstStyle/>
+          <a:p>
+            <a:pPr algn="ctr" indent="0" marL="0">
+              <a:buNone/>
+            </a:pPr>
+            <a:r>
+              <a:rPr lang="en-US" sz="2200" dirty="0">
+                <a:solidFill>
+                  <a:srgbClr val="F79E1B"/>
+                </a:solidFill>
+              </a:rPr>
+              <a:t>›</a:t>
+            </a:r>
+            <a:endParaRPr lang="en-US" sz="2200" dirty="0"/>
+          </a:p>
+        </p:txBody>
+      </p:sp>
+      <p:sp>
+        <p:nvSpPr>
+          <p:cNvPr id="16" name="Shape 12"/>
           <p:cNvSpPr/>
           <p:nvPr/>
         </p:nvSpPr>
         <p:spPr>
           <a:xfrm>
-            <a:off x="3822192" y="1325880"/>
-            <a:ext cx="1554480" cy="2560320"/>
+            <a:off x="3822192" y="1371600"/>
+            <a:ext cx="1554480" cy="2240280"/>
           </a:xfrm>
           <a:prstGeom prst="roundRect">
             <a:avLst>
@@ -4064,13 +4172,13 @@
       </p:sp>
       <p:sp>
         <p:nvSpPr>
-          <p:cNvPr id="14" name="Shape 10"/>
+          <p:cNvPr id="17" name="Shape 13"/>
           <p:cNvSpPr/>
           <p:nvPr/>
         </p:nvSpPr>
         <p:spPr>
           <a:xfrm>
-            <a:off x="3904488" y="1435608"/>
+            <a:off x="3904488" y="1472184"/>
             <a:ext cx="530352" cy="530352"/>
           </a:xfrm>
           <a:prstGeom prst="ellipse">
@@ -4089,7 +4197,7 @@
       </p:sp>
       <p:pic>
         <p:nvPicPr>
-          <p:cNvPr id="15" name="Image 2" descr="preencoded.png">    </p:cNvPr>
+          <p:cNvPr id="18" name="Image 2" descr="preencoded.png">    </p:cNvPr>
           <p:cNvPicPr>
             <a:picLocks noChangeAspect="1"/>
           </p:cNvPicPr>
@@ -4103,7 +4211,7 @@
         </p:blipFill>
         <p:spPr>
           <a:xfrm>
-            <a:off x="4005072" y="1536192"/>
+            <a:off x="4005072" y="1572768"/>
             <a:ext cx="329184" cy="329184"/>
           </a:xfrm>
           <a:prstGeom prst="rect">
@@ -4113,14 +4221,14 @@
       </p:pic>
       <p:sp>
         <p:nvSpPr>
-          <p:cNvPr id="16" name="Text 11"/>
-          <p:cNvSpPr txBox="1"/>
-          <p:nvPr/>
-        </p:nvSpPr>
-        <p:spPr>
-          <a:xfrm>
-            <a:off x="3959352" y="2103120"/>
-            <a:ext cx="1325880" cy="320040"/>
+          <p:cNvPr id="19" name="Text 14"/>
+          <p:cNvSpPr txBox="1"/>
+          <p:nvPr/>
+        </p:nvSpPr>
+        <p:spPr>
+          <a:xfrm>
+            <a:off x="3959352" y="2121408"/>
+            <a:ext cx="1325880" cy="292608"/>
           </a:xfrm>
           <a:prstGeom prst="rect">
             <a:avLst/>
@@ -4141,7 +4249,7 @@
                   <a:srgbClr val="FFFFFF"/>
                 </a:solidFill>
               </a:rPr>
-              <a:t>3  Agent prepares</a:t>
+              <a:t>Agent prepares</a:t>
             </a:r>
             <a:endParaRPr lang="en-US" sz="1250" dirty="0"/>
           </a:p>
@@ -4149,14 +4257,14 @@
       </p:sp>
       <p:sp>
         <p:nvSpPr>
-          <p:cNvPr id="17" name="Text 12"/>
-          <p:cNvSpPr txBox="1"/>
-          <p:nvPr/>
-        </p:nvSpPr>
-        <p:spPr>
-          <a:xfrm>
-            <a:off x="3959352" y="2450592"/>
-            <a:ext cx="1325880" cy="1371600"/>
+          <p:cNvPr id="20" name="Text 15"/>
+          <p:cNvSpPr txBox="1"/>
+          <p:nvPr/>
+        </p:nvSpPr>
+        <p:spPr>
+          <a:xfrm>
+            <a:off x="3959352" y="2432304"/>
+            <a:ext cx="1325880" cy="1143000"/>
           </a:xfrm>
           <a:prstGeom prst="rect">
             <a:avLst/>
@@ -4172,27 +4280,63 @@
               <a:buNone/>
             </a:pPr>
             <a:r>
-              <a:rPr lang="en-US" sz="1050" dirty="0">
+              <a:rPr lang="en-US" sz="1000" dirty="0">
                 <a:solidFill>
                   <a:srgbClr val="C9CBD3"/>
                 </a:solidFill>
               </a:rPr>
-              <a:t>Azure AI Foundry agent on an open model drafts the Bicep and a risk memo. Read-only.</a:t>
-            </a:r>
-            <a:endParaRPr lang="en-US" sz="1050" dirty="0"/>
-          </a:p>
-        </p:txBody>
-      </p:sp>
-      <p:sp>
-        <p:nvSpPr>
-          <p:cNvPr id="18" name="Shape 13"/>
+              <a:t>An Azure AI Foundry agent drafts the Bicep and a risk memo. Read-only; it never approves.</a:t>
+            </a:r>
+            <a:endParaRPr lang="en-US" sz="1000" dirty="0"/>
+          </a:p>
+        </p:txBody>
+      </p:sp>
+      <p:sp>
+        <p:nvSpPr>
+          <p:cNvPr id="21" name="Text 16"/>
+          <p:cNvSpPr txBox="1"/>
+          <p:nvPr/>
+        </p:nvSpPr>
+        <p:spPr>
+          <a:xfrm>
+            <a:off x="5340096" y="2240280"/>
+            <a:ext cx="228600" cy="365760"/>
+          </a:xfrm>
+          <a:prstGeom prst="rect">
+            <a:avLst/>
+          </a:prstGeom>
+          <a:noFill/>
+          <a:ln/>
+        </p:spPr>
+        <p:txBody>
+          <a:bodyPr wrap="square" lIns="0" tIns="0" rIns="0" bIns="0" rtlCol="0" anchor="ctr"/>
+          <a:lstStyle/>
+          <a:p>
+            <a:pPr algn="ctr" indent="0" marL="0">
+              <a:buNone/>
+            </a:pPr>
+            <a:r>
+              <a:rPr lang="en-US" sz="2200" dirty="0">
+                <a:solidFill>
+                  <a:srgbClr val="F79E1B"/>
+                </a:solidFill>
+              </a:rPr>
+              <a:t>›</a:t>
+            </a:r>
+            <a:endParaRPr lang="en-US" sz="2200" dirty="0"/>
+          </a:p>
+        </p:txBody>
+      </p:sp>
+      <p:sp>
+        <p:nvSpPr>
+          <p:cNvPr id="22" name="Shape 17"/>
           <p:cNvSpPr/>
           <p:nvPr/>
         </p:nvSpPr>
         <p:spPr>
           <a:xfrm>
-            <a:off x="5504688" y="1325880"/>
-            <a:ext cx="1554480" cy="2560320"/>
+            <a:off x="5504688" y="1371600"/>
+            <a:ext cx="1554480" cy="2240280"/>
           </a:xfrm>
           <a:prstGeom prst="roundRect">
             <a:avLst>
@@ -4214,13 +4358,13 @@
       </p:sp>
       <p:sp>
         <p:nvSpPr>
-          <p:cNvPr id="19" name="Shape 14"/>
+          <p:cNvPr id="23" name="Shape 18"/>
           <p:cNvSpPr/>
           <p:nvPr/>
         </p:nvSpPr>
         <p:spPr>
           <a:xfrm>
-            <a:off x="5586984" y="1435608"/>
+            <a:off x="5586984" y="1472184"/>
             <a:ext cx="530352" cy="530352"/>
           </a:xfrm>
           <a:prstGeom prst="ellipse">
@@ -4239,7 +4383,7 @@
       </p:sp>
       <p:pic>
         <p:nvPicPr>
-          <p:cNvPr id="20" name="Image 3" descr="preencoded.png">    </p:cNvPr>
+          <p:cNvPr id="24" name="Image 3" descr="preencoded.png">    </p:cNvPr>
           <p:cNvPicPr>
             <a:picLocks noChangeAspect="1"/>
           </p:cNvPicPr>
@@ -4253,7 +4397,7 @@
         </p:blipFill>
         <p:spPr>
           <a:xfrm>
-            <a:off x="5687568" y="1536192"/>
+            <a:off x="5687568" y="1572768"/>
             <a:ext cx="329184" cy="329184"/>
           </a:xfrm>
           <a:prstGeom prst="rect">
@@ -4263,14 +4407,14 @@
       </p:pic>
       <p:sp>
         <p:nvSpPr>
-          <p:cNvPr id="21" name="Text 15"/>
-          <p:cNvSpPr txBox="1"/>
-          <p:nvPr/>
-        </p:nvSpPr>
-        <p:spPr>
-          <a:xfrm>
-            <a:off x="5641848" y="2103120"/>
-            <a:ext cx="1325880" cy="320040"/>
+          <p:cNvPr id="25" name="Text 19"/>
+          <p:cNvSpPr txBox="1"/>
+          <p:nvPr/>
+        </p:nvSpPr>
+        <p:spPr>
+          <a:xfrm>
+            <a:off x="5641848" y="2121408"/>
+            <a:ext cx="1325880" cy="292608"/>
           </a:xfrm>
           <a:prstGeom prst="rect">
             <a:avLst/>
@@ -4291,7 +4435,7 @@
                   <a:srgbClr val="FFFFFF"/>
                 </a:solidFill>
               </a:rPr>
-              <a:t>4  People approve</a:t>
+              <a:t>People approve</a:t>
             </a:r>
             <a:endParaRPr lang="en-US" sz="1250" dirty="0"/>
           </a:p>
@@ -4299,14 +4443,14 @@
       </p:sp>
       <p:sp>
         <p:nvSpPr>
-          <p:cNvPr id="22" name="Text 16"/>
-          <p:cNvSpPr txBox="1"/>
-          <p:nvPr/>
-        </p:nvSpPr>
-        <p:spPr>
-          <a:xfrm>
-            <a:off x="5641848" y="2450592"/>
-            <a:ext cx="1325880" cy="1371600"/>
+          <p:cNvPr id="26" name="Text 20"/>
+          <p:cNvSpPr txBox="1"/>
+          <p:nvPr/>
+        </p:nvSpPr>
+        <p:spPr>
+          <a:xfrm>
+            <a:off x="5641848" y="2432304"/>
+            <a:ext cx="1325880" cy="1143000"/>
           </a:xfrm>
           <a:prstGeom prst="rect">
             <a:avLst/>
@@ -4322,27 +4466,63 @@
               <a:buNone/>
             </a:pPr>
             <a:r>
-              <a:rPr lang="en-US" sz="1050" dirty="0">
+              <a:rPr lang="en-US" sz="1000" dirty="0">
                 <a:solidFill>
                   <a:srgbClr val="C9CBD3"/>
                 </a:solidFill>
               </a:rPr>
-              <a:t>Only the approvals that must stay human, in parallel. A GitHub gate enforces it.</a:t>
-            </a:r>
-            <a:endParaRPr lang="en-US" sz="1050" dirty="0"/>
-          </a:p>
-        </p:txBody>
-      </p:sp>
-      <p:sp>
-        <p:nvSpPr>
-          <p:cNvPr id="23" name="Shape 17"/>
+              <a:t>Only the approvals that must stay human, in parallel. A GitHub gate blocks deployment until they sign.</a:t>
+            </a:r>
+            <a:endParaRPr lang="en-US" sz="1000" dirty="0"/>
+          </a:p>
+        </p:txBody>
+      </p:sp>
+      <p:sp>
+        <p:nvSpPr>
+          <p:cNvPr id="27" name="Text 21"/>
+          <p:cNvSpPr txBox="1"/>
+          <p:nvPr/>
+        </p:nvSpPr>
+        <p:spPr>
+          <a:xfrm>
+            <a:off x="7022592" y="2240280"/>
+            <a:ext cx="228600" cy="365760"/>
+          </a:xfrm>
+          <a:prstGeom prst="rect">
+            <a:avLst/>
+          </a:prstGeom>
+          <a:noFill/>
+          <a:ln/>
+        </p:spPr>
+        <p:txBody>
+          <a:bodyPr wrap="square" lIns="0" tIns="0" rIns="0" bIns="0" rtlCol="0" anchor="ctr"/>
+          <a:lstStyle/>
+          <a:p>
+            <a:pPr algn="ctr" indent="0" marL="0">
+              <a:buNone/>
+            </a:pPr>
+            <a:r>
+              <a:rPr lang="en-US" sz="2200" dirty="0">
+                <a:solidFill>
+                  <a:srgbClr val="F79E1B"/>
+                </a:solidFill>
+              </a:rPr>
+              <a:t>›</a:t>
+            </a:r>
+            <a:endParaRPr lang="en-US" sz="2200" dirty="0"/>
+          </a:p>
+        </p:txBody>
+      </p:sp>
+      <p:sp>
+        <p:nvSpPr>
+          <p:cNvPr id="28" name="Shape 22"/>
           <p:cNvSpPr/>
           <p:nvPr/>
         </p:nvSpPr>
         <p:spPr>
           <a:xfrm>
-            <a:off x="7187184" y="1325880"/>
-            <a:ext cx="1554480" cy="2560320"/>
+            <a:off x="7187184" y="1371600"/>
+            <a:ext cx="1554480" cy="2240280"/>
           </a:xfrm>
           <a:prstGeom prst="roundRect">
             <a:avLst>
@@ -4364,13 +4544,13 @@
       </p:sp>
       <p:sp>
         <p:nvSpPr>
-          <p:cNvPr id="24" name="Shape 18"/>
+          <p:cNvPr id="29" name="Shape 23"/>
           <p:cNvSpPr/>
           <p:nvPr/>
         </p:nvSpPr>
         <p:spPr>
           <a:xfrm>
-            <a:off x="7269480" y="1435608"/>
+            <a:off x="7269480" y="1472184"/>
             <a:ext cx="530352" cy="530352"/>
           </a:xfrm>
           <a:prstGeom prst="ellipse">
@@ -4389,7 +4569,7 @@
       </p:sp>
       <p:pic>
         <p:nvPicPr>
-          <p:cNvPr id="25" name="Image 4" descr="preencoded.png">    </p:cNvPr>
+          <p:cNvPr id="30" name="Image 4" descr="preencoded.png">    </p:cNvPr>
           <p:cNvPicPr>
             <a:picLocks noChangeAspect="1"/>
           </p:cNvPicPr>
@@ -4403,7 +4583,7 @@
         </p:blipFill>
         <p:spPr>
           <a:xfrm>
-            <a:off x="7370064" y="1536192"/>
+            <a:off x="7370064" y="1572768"/>
             <a:ext cx="329184" cy="329184"/>
           </a:xfrm>
           <a:prstGeom prst="rect">
@@ -4413,14 +4593,14 @@
       </p:pic>
       <p:sp>
         <p:nvSpPr>
-          <p:cNvPr id="26" name="Text 19"/>
-          <p:cNvSpPr txBox="1"/>
-          <p:nvPr/>
-        </p:nvSpPr>
-        <p:spPr>
-          <a:xfrm>
-            <a:off x="7324344" y="2103120"/>
-            <a:ext cx="1325880" cy="320040"/>
+          <p:cNvPr id="31" name="Text 24"/>
+          <p:cNvSpPr txBox="1"/>
+          <p:nvPr/>
+        </p:nvSpPr>
+        <p:spPr>
+          <a:xfrm>
+            <a:off x="7324344" y="2121408"/>
+            <a:ext cx="1325880" cy="292608"/>
           </a:xfrm>
           <a:prstGeom prst="rect">
             <a:avLst/>
@@ -4441,7 +4621,7 @@
                   <a:srgbClr val="FFFFFF"/>
                 </a:solidFill>
               </a:rPr>
-              <a:t>5  All logged</a:t>
+              <a:t>Evidence written</a:t>
             </a:r>
             <a:endParaRPr lang="en-US" sz="1250" dirty="0"/>
           </a:p>
@@ -4449,14 +4629,14 @@
       </p:sp>
       <p:sp>
         <p:nvSpPr>
-          <p:cNvPr id="27" name="Text 20"/>
-          <p:cNvSpPr txBox="1"/>
-          <p:nvPr/>
-        </p:nvSpPr>
-        <p:spPr>
-          <a:xfrm>
-            <a:off x="7324344" y="2450592"/>
-            <a:ext cx="1325880" cy="1371600"/>
+          <p:cNvPr id="32" name="Text 25"/>
+          <p:cNvSpPr txBox="1"/>
+          <p:nvPr/>
+        </p:nvSpPr>
+        <p:spPr>
+          <a:xfrm>
+            <a:off x="7324344" y="2432304"/>
+            <a:ext cx="1325880" cy="1143000"/>
           </a:xfrm>
           <a:prstGeom prst="rect">
             <a:avLst/>
@@ -4472,27 +4652,114 @@
               <a:buNone/>
             </a:pPr>
             <a:r>
-              <a:rPr lang="en-US" sz="1050" dirty="0">
+              <a:rPr lang="en-US" sz="1000" dirty="0">
                 <a:solidFill>
                   <a:srgbClr val="C9CBD3"/>
                 </a:solidFill>
               </a:rPr>
-              <a:t>Append-only audit trail; the evidence pack a partner bank asks for is already written.</a:t>
-            </a:r>
-            <a:endParaRPr lang="en-US" sz="1050" dirty="0"/>
-          </a:p>
-        </p:txBody>
-      </p:sp>
-      <p:sp>
-        <p:nvSpPr>
-          <p:cNvPr id="28" name="Text 21"/>
-          <p:cNvSpPr txBox="1"/>
-          <p:nvPr/>
-        </p:nvSpPr>
-        <p:spPr>
-          <a:xfrm>
-            <a:off x="457200" y="4069080"/>
-            <a:ext cx="8229600" cy="502920"/>
+              <a:t>Append-only audit trail. The pack a partner bank or auditor asks for already exists.</a:t>
+            </a:r>
+            <a:endParaRPr lang="en-US" sz="1000" dirty="0"/>
+          </a:p>
+        </p:txBody>
+      </p:sp>
+      <p:sp>
+        <p:nvSpPr>
+          <p:cNvPr id="33" name="Shape 26"/>
+          <p:cNvSpPr/>
+          <p:nvPr/>
+        </p:nvSpPr>
+        <p:spPr>
+          <a:xfrm>
+            <a:off x="457200" y="3749040"/>
+            <a:ext cx="2651760" cy="868680"/>
+          </a:xfrm>
+          <a:prstGeom prst="roundRect">
+            <a:avLst>
+              <a:gd name="adj" fmla="val 14737"/>
+            </a:avLst>
+          </a:prstGeom>
+          <a:solidFill>
+            <a:srgbClr val="1F1414">
+              <a:alpha val="88000"/>
+            </a:srgbClr>
+          </a:solidFill>
+          <a:ln w="9525">
+            <a:solidFill>
+              <a:srgbClr val="2A2A30"/>
+            </a:solidFill>
+            <a:prstDash val="solid"/>
+          </a:ln>
+        </p:spPr>
+      </p:sp>
+      <p:sp>
+        <p:nvSpPr>
+          <p:cNvPr id="34" name="Shape 27"/>
+          <p:cNvSpPr/>
+          <p:nvPr/>
+        </p:nvSpPr>
+        <p:spPr>
+          <a:xfrm>
+            <a:off x="3246120" y="3749040"/>
+            <a:ext cx="2651760" cy="868680"/>
+          </a:xfrm>
+          <a:prstGeom prst="roundRect">
+            <a:avLst>
+              <a:gd name="adj" fmla="val 14737"/>
+            </a:avLst>
+          </a:prstGeom>
+          <a:solidFill>
+            <a:srgbClr val="12201A">
+              <a:alpha val="88000"/>
+            </a:srgbClr>
+          </a:solidFill>
+          <a:ln w="9525">
+            <a:solidFill>
+              <a:srgbClr val="2A2A30"/>
+            </a:solidFill>
+            <a:prstDash val="solid"/>
+          </a:ln>
+        </p:spPr>
+      </p:sp>
+      <p:sp>
+        <p:nvSpPr>
+          <p:cNvPr id="35" name="Shape 28"/>
+          <p:cNvSpPr/>
+          <p:nvPr/>
+        </p:nvSpPr>
+        <p:spPr>
+          <a:xfrm>
+            <a:off x="6035040" y="3749040"/>
+            <a:ext cx="2651760" cy="868680"/>
+          </a:xfrm>
+          <a:prstGeom prst="roundRect">
+            <a:avLst>
+              <a:gd name="adj" fmla="val 14737"/>
+            </a:avLst>
+          </a:prstGeom>
+          <a:solidFill>
+            <a:srgbClr val="1A1A1E">
+              <a:alpha val="88000"/>
+            </a:srgbClr>
+          </a:solidFill>
+          <a:ln w="9525">
+            <a:solidFill>
+              <a:srgbClr val="2A2A30"/>
+            </a:solidFill>
+            <a:prstDash val="solid"/>
+          </a:ln>
+        </p:spPr>
+      </p:sp>
+      <p:sp>
+        <p:nvSpPr>
+          <p:cNvPr id="36" name="Text 29"/>
+          <p:cNvSpPr txBox="1"/>
+          <p:nvPr/>
+        </p:nvSpPr>
+        <p:spPr>
+          <a:xfrm>
+            <a:off x="640080" y="3803904"/>
+            <a:ext cx="2286000" cy="228600"/>
           </a:xfrm>
           <a:prstGeom prst="rect">
             <a:avLst/>
@@ -4508,14 +4775,194 @@
               <a:buNone/>
             </a:pPr>
             <a:r>
-              <a:rPr lang="en-US" sz="1300" dirty="0">
+              <a:rPr lang="en-US" sz="1000" b="1" dirty="0">
+                <a:solidFill>
+                  <a:srgbClr val="EB001B"/>
+                </a:solidFill>
+              </a:rPr>
+              <a:t>Today</a:t>
+            </a:r>
+            <a:endParaRPr lang="en-US" sz="1000" dirty="0"/>
+          </a:p>
+        </p:txBody>
+      </p:sp>
+      <p:sp>
+        <p:nvSpPr>
+          <p:cNvPr id="37" name="Text 30"/>
+          <p:cNvSpPr txBox="1"/>
+          <p:nvPr/>
+        </p:nvSpPr>
+        <p:spPr>
+          <a:xfrm>
+            <a:off x="640080" y="4041648"/>
+            <a:ext cx="2377440" cy="457200"/>
+          </a:xfrm>
+          <a:prstGeom prst="rect">
+            <a:avLst/>
+          </a:prstGeom>
+          <a:noFill/>
+          <a:ln/>
+        </p:spPr>
+        <p:txBody>
+          <a:bodyPr wrap="square" lIns="0" tIns="0" rIns="0" bIns="0" rtlCol="0" anchor="ctr"/>
+          <a:lstStyle/>
+          <a:p>
+            <a:pPr indent="0" marL="0">
+              <a:buNone/>
+            </a:pPr>
+            <a:r>
+              <a:rPr lang="en-US" sz="1400" b="1" dirty="0">
                 <a:solidFill>
                   <a:srgbClr val="FFFFFF"/>
                 </a:solidFill>
               </a:rPr>
-              <a:t>Twelve handoffs become one request plus only the human approvals policy requires. Eight steps automated, three merged into the request. Nothing deploys without a person.</a:t>
-            </a:r>
-            <a:endParaRPr lang="en-US" sz="1300" dirty="0"/>
+              <a:t>12 handoffs, 6 to 8 months</a:t>
+            </a:r>
+            <a:endParaRPr lang="en-US" sz="1400" dirty="0"/>
+          </a:p>
+        </p:txBody>
+      </p:sp>
+      <p:sp>
+        <p:nvSpPr>
+          <p:cNvPr id="38" name="Text 31"/>
+          <p:cNvSpPr txBox="1"/>
+          <p:nvPr/>
+        </p:nvSpPr>
+        <p:spPr>
+          <a:xfrm>
+            <a:off x="3429000" y="3803904"/>
+            <a:ext cx="2286000" cy="228600"/>
+          </a:xfrm>
+          <a:prstGeom prst="rect">
+            <a:avLst/>
+          </a:prstGeom>
+          <a:noFill/>
+          <a:ln/>
+        </p:spPr>
+        <p:txBody>
+          <a:bodyPr wrap="square" lIns="0" tIns="0" rIns="0" bIns="0" rtlCol="0" anchor="ctr"/>
+          <a:lstStyle/>
+          <a:p>
+            <a:pPr indent="0" marL="0">
+              <a:buNone/>
+            </a:pPr>
+            <a:r>
+              <a:rPr lang="en-US" sz="1000" b="1" dirty="0">
+                <a:solidFill>
+                  <a:srgbClr val="2ED573"/>
+                </a:solidFill>
+              </a:rPr>
+              <a:t>With LaunchGate</a:t>
+            </a:r>
+            <a:endParaRPr lang="en-US" sz="1000" dirty="0"/>
+          </a:p>
+        </p:txBody>
+      </p:sp>
+      <p:sp>
+        <p:nvSpPr>
+          <p:cNvPr id="39" name="Text 32"/>
+          <p:cNvSpPr txBox="1"/>
+          <p:nvPr/>
+        </p:nvSpPr>
+        <p:spPr>
+          <a:xfrm>
+            <a:off x="3429000" y="4041648"/>
+            <a:ext cx="2377440" cy="457200"/>
+          </a:xfrm>
+          <a:prstGeom prst="rect">
+            <a:avLst/>
+          </a:prstGeom>
+          <a:noFill/>
+          <a:ln/>
+        </p:spPr>
+        <p:txBody>
+          <a:bodyPr wrap="square" lIns="0" tIns="0" rIns="0" bIns="0" rtlCol="0" anchor="ctr"/>
+          <a:lstStyle/>
+          <a:p>
+            <a:pPr indent="0" marL="0">
+              <a:buNone/>
+            </a:pPr>
+            <a:r>
+              <a:rPr lang="en-US" sz="1400" b="1" dirty="0">
+                <a:solidFill>
+                  <a:srgbClr val="FFFFFF"/>
+                </a:solidFill>
+              </a:rPr>
+              <a:t>1 request + 1 to 2 human approvals</a:t>
+            </a:r>
+            <a:endParaRPr lang="en-US" sz="1400" dirty="0"/>
+          </a:p>
+        </p:txBody>
+      </p:sp>
+      <p:sp>
+        <p:nvSpPr>
+          <p:cNvPr id="40" name="Text 33"/>
+          <p:cNvSpPr txBox="1"/>
+          <p:nvPr/>
+        </p:nvSpPr>
+        <p:spPr>
+          <a:xfrm>
+            <a:off x="6217920" y="3803904"/>
+            <a:ext cx="2286000" cy="228600"/>
+          </a:xfrm>
+          <a:prstGeom prst="rect">
+            <a:avLst/>
+          </a:prstGeom>
+          <a:noFill/>
+          <a:ln/>
+        </p:spPr>
+        <p:txBody>
+          <a:bodyPr wrap="square" lIns="0" tIns="0" rIns="0" bIns="0" rtlCol="0" anchor="ctr"/>
+          <a:lstStyle/>
+          <a:p>
+            <a:pPr indent="0" marL="0">
+              <a:buNone/>
+            </a:pPr>
+            <a:r>
+              <a:rPr lang="en-US" sz="1000" b="1" dirty="0">
+                <a:solidFill>
+                  <a:srgbClr val="F79E1B"/>
+                </a:solidFill>
+              </a:rPr>
+              <a:t>What never changes</a:t>
+            </a:r>
+            <a:endParaRPr lang="en-US" sz="1000" dirty="0"/>
+          </a:p>
+        </p:txBody>
+      </p:sp>
+      <p:sp>
+        <p:nvSpPr>
+          <p:cNvPr id="41" name="Text 34"/>
+          <p:cNvSpPr txBox="1"/>
+          <p:nvPr/>
+        </p:nvSpPr>
+        <p:spPr>
+          <a:xfrm>
+            <a:off x="6217920" y="4041648"/>
+            <a:ext cx="2377440" cy="457200"/>
+          </a:xfrm>
+          <a:prstGeom prst="rect">
+            <a:avLst/>
+          </a:prstGeom>
+          <a:noFill/>
+          <a:ln/>
+        </p:spPr>
+        <p:txBody>
+          <a:bodyPr wrap="square" lIns="0" tIns="0" rIns="0" bIns="0" rtlCol="0" anchor="ctr"/>
+          <a:lstStyle/>
+          <a:p>
+            <a:pPr indent="0" marL="0">
+              <a:buNone/>
+            </a:pPr>
+            <a:r>
+              <a:rPr lang="en-US" sz="1400" b="1" dirty="0">
+                <a:solidFill>
+                  <a:srgbClr val="FFFFFF"/>
+                </a:solidFill>
+              </a:rPr>
+              <a:t>Nothing deploys without a person</a:t>
+            </a:r>
+            <a:endParaRPr lang="en-US" sz="1400" dirty="0"/>
           </a:p>
         </p:txBody>
       </p:sp>

</xml_diff>

<commit_message>
docs: simpler solution slide
Co-Authored-By: Claude Fable 5.1 <noreply@anthropic.com>
Claude-Session: https://claude.ai/code/session_01CjStCNcmtSU9WNnudUPSMi
</commit_message>
<xml_diff>
--- a/docs/LaunchGate-Pitch-v2.pptx
+++ b/docs/LaunchGate-Pitch-v2.pptx
@@ -3727,7 +3727,7 @@
                   <a:srgbClr val="FFFFFF"/>
                 </a:solidFill>
               </a:rPr>
-              <a:t>LaunchGate: one request, governed end to end</a:t>
+              <a:t>One request. Three steps. Nothing deploys without a person.</a:t>
             </a:r>
             <a:endParaRPr lang="en-US" sz="2800" dirty="0"/>
           </a:p>
@@ -3735,54 +3735,18 @@
       </p:sp>
       <p:sp>
         <p:nvSpPr>
-          <p:cNvPr id="3" name="Text 1"/>
-          <p:cNvSpPr txBox="1"/>
-          <p:nvPr/>
-        </p:nvSpPr>
-        <p:spPr>
-          <a:xfrm>
-            <a:off x="457200" y="868680"/>
-            <a:ext cx="8229600" cy="320040"/>
-          </a:xfrm>
-          <a:prstGeom prst="rect">
-            <a:avLst/>
-          </a:prstGeom>
-          <a:noFill/>
-          <a:ln/>
-        </p:spPr>
-        <p:txBody>
-          <a:bodyPr wrap="square" lIns="0" tIns="0" rIns="0" bIns="0" rtlCol="0" anchor="ctr"/>
-          <a:lstStyle/>
-          <a:p>
-            <a:pPr indent="0" marL="0">
-              <a:buNone/>
-            </a:pPr>
-            <a:r>
-              <a:rPr lang="en-US" sz="1500" dirty="0">
-                <a:solidFill>
-                  <a:srgbClr val="F79E1B"/>
-                </a:solidFill>
-              </a:rPr>
-              <a:t>Agents prepare. Rules decide. People approve.</a:t>
-            </a:r>
-            <a:endParaRPr lang="en-US" sz="1500" dirty="0"/>
-          </a:p>
-        </p:txBody>
-      </p:sp>
-      <p:sp>
-        <p:nvSpPr>
-          <p:cNvPr id="4" name="Shape 2"/>
+          <p:cNvPr id="3" name="Shape 1"/>
           <p:cNvSpPr/>
           <p:nvPr/>
         </p:nvSpPr>
         <p:spPr>
           <a:xfrm>
-            <a:off x="457200" y="1371600"/>
-            <a:ext cx="1554480" cy="2240280"/>
+            <a:off x="457200" y="1417320"/>
+            <a:ext cx="2651760" cy="2148840"/>
           </a:xfrm>
           <a:prstGeom prst="roundRect">
             <a:avLst>
-              <a:gd name="adj" fmla="val 8235"/>
+              <a:gd name="adj" fmla="val 5957"/>
             </a:avLst>
           </a:prstGeom>
           <a:solidFill>
@@ -3800,14 +3764,14 @@
       </p:sp>
       <p:sp>
         <p:nvSpPr>
-          <p:cNvPr id="5" name="Shape 3"/>
+          <p:cNvPr id="4" name="Shape 2"/>
           <p:cNvSpPr/>
           <p:nvPr/>
         </p:nvSpPr>
         <p:spPr>
           <a:xfrm>
-            <a:off x="539496" y="1472184"/>
-            <a:ext cx="530352" cy="530352"/>
+            <a:off x="630936" y="1591056"/>
+            <a:ext cx="621792" cy="621792"/>
           </a:xfrm>
           <a:prstGeom prst="ellipse">
             <a:avLst/>
@@ -3825,7 +3789,7 @@
       </p:sp>
       <p:pic>
         <p:nvPicPr>
-          <p:cNvPr id="6" name="Image 0" descr="preencoded.png">    </p:cNvPr>
+          <p:cNvPr id="5" name="Image 0" descr="preencoded.png">    </p:cNvPr>
           <p:cNvPicPr>
             <a:picLocks noChangeAspect="1"/>
           </p:cNvPicPr>
@@ -3839,8 +3803,8 @@
         </p:blipFill>
         <p:spPr>
           <a:xfrm>
-            <a:off x="640080" y="1572768"/>
-            <a:ext cx="329184" cy="329184"/>
+            <a:off x="731520" y="1691640"/>
+            <a:ext cx="420624" cy="420624"/>
           </a:xfrm>
           <a:prstGeom prst="rect">
             <a:avLst/>
@@ -3849,14 +3813,86 @@
       </p:pic>
       <p:sp>
         <p:nvSpPr>
+          <p:cNvPr id="6" name="Text 3"/>
+          <p:cNvSpPr txBox="1"/>
+          <p:nvPr/>
+        </p:nvSpPr>
+        <p:spPr>
+          <a:xfrm>
+            <a:off x="731520" y="2377440"/>
+            <a:ext cx="2194560" cy="411480"/>
+          </a:xfrm>
+          <a:prstGeom prst="rect">
+            <a:avLst/>
+          </a:prstGeom>
+          <a:noFill/>
+          <a:ln/>
+        </p:spPr>
+        <p:txBody>
+          <a:bodyPr wrap="square" lIns="0" tIns="0" rIns="0" bIns="0" rtlCol="0" anchor="ctr"/>
+          <a:lstStyle/>
+          <a:p>
+            <a:pPr indent="0" marL="0">
+              <a:buNone/>
+            </a:pPr>
+            <a:r>
+              <a:rPr lang="en-US" sz="2200" b="1" dirty="0">
+                <a:solidFill>
+                  <a:srgbClr val="FFFFFF"/>
+                </a:solidFill>
+              </a:rPr>
+              <a:t>Ask</a:t>
+            </a:r>
+            <a:endParaRPr lang="en-US" sz="2200" dirty="0"/>
+          </a:p>
+        </p:txBody>
+      </p:sp>
+      <p:sp>
+        <p:nvSpPr>
           <p:cNvPr id="7" name="Text 4"/>
           <p:cNvSpPr txBox="1"/>
           <p:nvPr/>
         </p:nvSpPr>
         <p:spPr>
           <a:xfrm>
-            <a:off x="594360" y="2121408"/>
-            <a:ext cx="1325880" cy="292608"/>
+            <a:off x="731520" y="2816352"/>
+            <a:ext cx="2194560" cy="731520"/>
+          </a:xfrm>
+          <a:prstGeom prst="rect">
+            <a:avLst/>
+          </a:prstGeom>
+          <a:noFill/>
+          <a:ln/>
+        </p:spPr>
+        <p:txBody>
+          <a:bodyPr wrap="square" lIns="0" tIns="0" rIns="0" bIns="0" rtlCol="0" anchor="t"/>
+          <a:lstStyle/>
+          <a:p>
+            <a:pPr indent="0" marL="0">
+              <a:buNone/>
+            </a:pPr>
+            <a:r>
+              <a:rPr lang="en-US" sz="1250" dirty="0">
+                <a:solidFill>
+                  <a:srgbClr val="C9CBD3"/>
+                </a:solidFill>
+              </a:rPr>
+              <a:t>Fill in one form. The rules check it instantly and tell you exactly what to fix.</a:t>
+            </a:r>
+            <a:endParaRPr lang="en-US" sz="1250" dirty="0"/>
+          </a:p>
+        </p:txBody>
+      </p:sp>
+      <p:sp>
+        <p:nvSpPr>
+          <p:cNvPr id="8" name="Text 5"/>
+          <p:cNvSpPr txBox="1"/>
+          <p:nvPr/>
+        </p:nvSpPr>
+        <p:spPr>
+          <a:xfrm>
+            <a:off x="3072384" y="2286000"/>
+            <a:ext cx="274320" cy="457200"/>
           </a:xfrm>
           <a:prstGeom prst="rect">
             <a:avLst/>
@@ -3868,107 +3904,35 @@
           <a:bodyPr wrap="square" lIns="0" tIns="0" rIns="0" bIns="0" rtlCol="0" anchor="ctr"/>
           <a:lstStyle/>
           <a:p>
-            <a:pPr indent="0" marL="0">
-              <a:buNone/>
-            </a:pPr>
-            <a:r>
-              <a:rPr lang="en-US" sz="1250" b="1" dirty="0">
-                <a:solidFill>
-                  <a:srgbClr val="FFFFFF"/>
-                </a:solidFill>
-              </a:rPr>
-              <a:t>Ask once</a:t>
-            </a:r>
-            <a:endParaRPr lang="en-US" sz="1250" dirty="0"/>
-          </a:p>
-        </p:txBody>
-      </p:sp>
-      <p:sp>
-        <p:nvSpPr>
-          <p:cNvPr id="8" name="Text 5"/>
-          <p:cNvSpPr txBox="1"/>
-          <p:nvPr/>
-        </p:nvSpPr>
-        <p:spPr>
-          <a:xfrm>
-            <a:off x="594360" y="2432304"/>
-            <a:ext cx="1325880" cy="1143000"/>
-          </a:xfrm>
-          <a:prstGeom prst="rect">
-            <a:avLst/>
-          </a:prstGeom>
-          <a:noFill/>
-          <a:ln/>
-        </p:spPr>
-        <p:txBody>
-          <a:bodyPr wrap="square" lIns="0" tIns="0" rIns="0" bIns="0" rtlCol="0" anchor="t"/>
-          <a:lstStyle/>
-          <a:p>
-            <a:pPr indent="0" marL="0">
-              <a:buNone/>
-            </a:pPr>
-            <a:r>
-              <a:rPr lang="en-US" sz="1000" dirty="0">
-                <a:solidFill>
-                  <a:srgbClr val="C9CBD3"/>
-                </a:solidFill>
-              </a:rPr>
-              <a:t>A business owner or engineer answers a few plain questions. Secure defaults are applied automatically.</a:t>
-            </a:r>
-            <a:endParaRPr lang="en-US" sz="1000" dirty="0"/>
-          </a:p>
-        </p:txBody>
-      </p:sp>
-      <p:sp>
-        <p:nvSpPr>
-          <p:cNvPr id="9" name="Text 6"/>
-          <p:cNvSpPr txBox="1"/>
-          <p:nvPr/>
-        </p:nvSpPr>
-        <p:spPr>
-          <a:xfrm>
-            <a:off x="1975104" y="2240280"/>
-            <a:ext cx="228600" cy="365760"/>
-          </a:xfrm>
-          <a:prstGeom prst="rect">
-            <a:avLst/>
-          </a:prstGeom>
-          <a:noFill/>
-          <a:ln/>
-        </p:spPr>
-        <p:txBody>
-          <a:bodyPr wrap="square" lIns="0" tIns="0" rIns="0" bIns="0" rtlCol="0" anchor="ctr"/>
-          <a:lstStyle/>
-          <a:p>
             <a:pPr algn="ctr" indent="0" marL="0">
               <a:buNone/>
             </a:pPr>
             <a:r>
-              <a:rPr lang="en-US" sz="2200" dirty="0">
+              <a:rPr lang="en-US" sz="2800" dirty="0">
                 <a:solidFill>
                   <a:srgbClr val="F79E1B"/>
                 </a:solidFill>
               </a:rPr>
               <a:t>›</a:t>
             </a:r>
-            <a:endParaRPr lang="en-US" sz="2200" dirty="0"/>
-          </a:p>
-        </p:txBody>
-      </p:sp>
-      <p:sp>
-        <p:nvSpPr>
-          <p:cNvPr id="10" name="Shape 7"/>
+            <a:endParaRPr lang="en-US" sz="2800" dirty="0"/>
+          </a:p>
+        </p:txBody>
+      </p:sp>
+      <p:sp>
+        <p:nvSpPr>
+          <p:cNvPr id="9" name="Shape 6"/>
           <p:cNvSpPr/>
           <p:nvPr/>
         </p:nvSpPr>
         <p:spPr>
           <a:xfrm>
-            <a:off x="2139696" y="1371600"/>
-            <a:ext cx="1554480" cy="2240280"/>
+            <a:off x="3246120" y="1417320"/>
+            <a:ext cx="2651760" cy="2148840"/>
           </a:xfrm>
           <a:prstGeom prst="roundRect">
             <a:avLst>
-              <a:gd name="adj" fmla="val 8235"/>
+              <a:gd name="adj" fmla="val 5957"/>
             </a:avLst>
           </a:prstGeom>
           <a:solidFill>
@@ -3986,14 +3950,14 @@
       </p:sp>
       <p:sp>
         <p:nvSpPr>
-          <p:cNvPr id="11" name="Shape 8"/>
+          <p:cNvPr id="10" name="Shape 7"/>
           <p:cNvSpPr/>
           <p:nvPr/>
         </p:nvSpPr>
         <p:spPr>
           <a:xfrm>
-            <a:off x="2221992" y="1472184"/>
-            <a:ext cx="530352" cy="530352"/>
+            <a:off x="3419856" y="1591056"/>
+            <a:ext cx="621792" cy="621792"/>
           </a:xfrm>
           <a:prstGeom prst="ellipse">
             <a:avLst/>
@@ -4011,7 +3975,7 @@
       </p:sp>
       <p:pic>
         <p:nvPicPr>
-          <p:cNvPr id="12" name="Image 1" descr="preencoded.png">    </p:cNvPr>
+          <p:cNvPr id="11" name="Image 1" descr="preencoded.png">    </p:cNvPr>
           <p:cNvPicPr>
             <a:picLocks noChangeAspect="1"/>
           </p:cNvPicPr>
@@ -4025,8 +3989,8 @@
         </p:blipFill>
         <p:spPr>
           <a:xfrm>
-            <a:off x="2322576" y="1572768"/>
-            <a:ext cx="329184" cy="329184"/>
+            <a:off x="3520440" y="1691640"/>
+            <a:ext cx="420624" cy="420624"/>
           </a:xfrm>
           <a:prstGeom prst="rect">
             <a:avLst/>
@@ -4035,14 +3999,86 @@
       </p:pic>
       <p:sp>
         <p:nvSpPr>
+          <p:cNvPr id="12" name="Text 8"/>
+          <p:cNvSpPr txBox="1"/>
+          <p:nvPr/>
+        </p:nvSpPr>
+        <p:spPr>
+          <a:xfrm>
+            <a:off x="3520440" y="2377440"/>
+            <a:ext cx="2194560" cy="411480"/>
+          </a:xfrm>
+          <a:prstGeom prst="rect">
+            <a:avLst/>
+          </a:prstGeom>
+          <a:noFill/>
+          <a:ln/>
+        </p:spPr>
+        <p:txBody>
+          <a:bodyPr wrap="square" lIns="0" tIns="0" rIns="0" bIns="0" rtlCol="0" anchor="ctr"/>
+          <a:lstStyle/>
+          <a:p>
+            <a:pPr indent="0" marL="0">
+              <a:buNone/>
+            </a:pPr>
+            <a:r>
+              <a:rPr lang="en-US" sz="2200" b="1" dirty="0">
+                <a:solidFill>
+                  <a:srgbClr val="FFFFFF"/>
+                </a:solidFill>
+              </a:rPr>
+              <a:t>Prepare</a:t>
+            </a:r>
+            <a:endParaRPr lang="en-US" sz="2200" dirty="0"/>
+          </a:p>
+        </p:txBody>
+      </p:sp>
+      <p:sp>
+        <p:nvSpPr>
           <p:cNvPr id="13" name="Text 9"/>
           <p:cNvSpPr txBox="1"/>
           <p:nvPr/>
         </p:nvSpPr>
         <p:spPr>
           <a:xfrm>
-            <a:off x="2276856" y="2121408"/>
-            <a:ext cx="1325880" cy="292608"/>
+            <a:off x="3520440" y="2816352"/>
+            <a:ext cx="2194560" cy="731520"/>
+          </a:xfrm>
+          <a:prstGeom prst="rect">
+            <a:avLst/>
+          </a:prstGeom>
+          <a:noFill/>
+          <a:ln/>
+        </p:spPr>
+        <p:txBody>
+          <a:bodyPr wrap="square" lIns="0" tIns="0" rIns="0" bIns="0" rtlCol="0" anchor="t"/>
+          <a:lstStyle/>
+          <a:p>
+            <a:pPr indent="0" marL="0">
+              <a:buNone/>
+            </a:pPr>
+            <a:r>
+              <a:rPr lang="en-US" sz="1250" dirty="0">
+                <a:solidFill>
+                  <a:srgbClr val="C9CBD3"/>
+                </a:solidFill>
+              </a:rPr>
+              <a:t>An AI agent writes the risk memo and the infrastructure code. It cannot approve anything.</a:t>
+            </a:r>
+            <a:endParaRPr lang="en-US" sz="1250" dirty="0"/>
+          </a:p>
+        </p:txBody>
+      </p:sp>
+      <p:sp>
+        <p:nvSpPr>
+          <p:cNvPr id="14" name="Text 10"/>
+          <p:cNvSpPr txBox="1"/>
+          <p:nvPr/>
+        </p:nvSpPr>
+        <p:spPr>
+          <a:xfrm>
+            <a:off x="5861304" y="2286000"/>
+            <a:ext cx="274320" cy="457200"/>
           </a:xfrm>
           <a:prstGeom prst="rect">
             <a:avLst/>
@@ -4054,107 +4090,35 @@
           <a:bodyPr wrap="square" lIns="0" tIns="0" rIns="0" bIns="0" rtlCol="0" anchor="ctr"/>
           <a:lstStyle/>
           <a:p>
-            <a:pPr indent="0" marL="0">
-              <a:buNone/>
-            </a:pPr>
-            <a:r>
-              <a:rPr lang="en-US" sz="1250" b="1" dirty="0">
-                <a:solidFill>
-                  <a:srgbClr val="FFFFFF"/>
-                </a:solidFill>
-              </a:rPr>
-              <a:t>Rules decide</a:t>
-            </a:r>
-            <a:endParaRPr lang="en-US" sz="1250" dirty="0"/>
-          </a:p>
-        </p:txBody>
-      </p:sp>
-      <p:sp>
-        <p:nvSpPr>
-          <p:cNvPr id="14" name="Text 10"/>
-          <p:cNvSpPr txBox="1"/>
-          <p:nvPr/>
-        </p:nvSpPr>
-        <p:spPr>
-          <a:xfrm>
-            <a:off x="2276856" y="2432304"/>
-            <a:ext cx="1325880" cy="1143000"/>
-          </a:xfrm>
-          <a:prstGeom prst="rect">
-            <a:avLst/>
-          </a:prstGeom>
-          <a:noFill/>
-          <a:ln/>
-        </p:spPr>
-        <p:txBody>
-          <a:bodyPr wrap="square" lIns="0" tIns="0" rIns="0" bIns="0" rtlCol="0" anchor="t"/>
-          <a:lstStyle/>
-          <a:p>
-            <a:pPr indent="0" marL="0">
-              <a:buNone/>
-            </a:pPr>
-            <a:r>
-              <a:rPr lang="en-US" sz="1000" dirty="0">
-                <a:solidFill>
-                  <a:srgbClr val="C9CBD3"/>
-                </a:solidFill>
-              </a:rPr>
-              <a:t>A deterministic model scores risk and runs every rule. Each result names the control it cites and the fix.</a:t>
-            </a:r>
-            <a:endParaRPr lang="en-US" sz="1000" dirty="0"/>
-          </a:p>
-        </p:txBody>
-      </p:sp>
-      <p:sp>
-        <p:nvSpPr>
-          <p:cNvPr id="15" name="Text 11"/>
-          <p:cNvSpPr txBox="1"/>
-          <p:nvPr/>
-        </p:nvSpPr>
-        <p:spPr>
-          <a:xfrm>
-            <a:off x="3657600" y="2240280"/>
-            <a:ext cx="228600" cy="365760"/>
-          </a:xfrm>
-          <a:prstGeom prst="rect">
-            <a:avLst/>
-          </a:prstGeom>
-          <a:noFill/>
-          <a:ln/>
-        </p:spPr>
-        <p:txBody>
-          <a:bodyPr wrap="square" lIns="0" tIns="0" rIns="0" bIns="0" rtlCol="0" anchor="ctr"/>
-          <a:lstStyle/>
-          <a:p>
             <a:pPr algn="ctr" indent="0" marL="0">
               <a:buNone/>
             </a:pPr>
             <a:r>
-              <a:rPr lang="en-US" sz="2200" dirty="0">
+              <a:rPr lang="en-US" sz="2800" dirty="0">
                 <a:solidFill>
                   <a:srgbClr val="F79E1B"/>
                 </a:solidFill>
               </a:rPr>
               <a:t>›</a:t>
             </a:r>
-            <a:endParaRPr lang="en-US" sz="2200" dirty="0"/>
-          </a:p>
-        </p:txBody>
-      </p:sp>
-      <p:sp>
-        <p:nvSpPr>
-          <p:cNvPr id="16" name="Shape 12"/>
+            <a:endParaRPr lang="en-US" sz="2800" dirty="0"/>
+          </a:p>
+        </p:txBody>
+      </p:sp>
+      <p:sp>
+        <p:nvSpPr>
+          <p:cNvPr id="15" name="Shape 11"/>
           <p:cNvSpPr/>
           <p:nvPr/>
         </p:nvSpPr>
         <p:spPr>
           <a:xfrm>
-            <a:off x="3822192" y="1371600"/>
-            <a:ext cx="1554480" cy="2240280"/>
+            <a:off x="6035040" y="1417320"/>
+            <a:ext cx="2651760" cy="2148840"/>
           </a:xfrm>
           <a:prstGeom prst="roundRect">
             <a:avLst>
-              <a:gd name="adj" fmla="val 8235"/>
+              <a:gd name="adj" fmla="val 5957"/>
             </a:avLst>
           </a:prstGeom>
           <a:solidFill>
@@ -4172,14 +4136,14 @@
       </p:sp>
       <p:sp>
         <p:nvSpPr>
-          <p:cNvPr id="17" name="Shape 13"/>
+          <p:cNvPr id="16" name="Shape 12"/>
           <p:cNvSpPr/>
           <p:nvPr/>
         </p:nvSpPr>
         <p:spPr>
           <a:xfrm>
-            <a:off x="3904488" y="1472184"/>
-            <a:ext cx="530352" cy="530352"/>
+            <a:off x="6208776" y="1591056"/>
+            <a:ext cx="621792" cy="621792"/>
           </a:xfrm>
           <a:prstGeom prst="ellipse">
             <a:avLst/>
@@ -4197,7 +4161,7 @@
       </p:sp>
       <p:pic>
         <p:nvPicPr>
-          <p:cNvPr id="18" name="Image 2" descr="preencoded.png">    </p:cNvPr>
+          <p:cNvPr id="17" name="Image 2" descr="preencoded.png">    </p:cNvPr>
           <p:cNvPicPr>
             <a:picLocks noChangeAspect="1"/>
           </p:cNvPicPr>
@@ -4211,8 +4175,8 @@
         </p:blipFill>
         <p:spPr>
           <a:xfrm>
-            <a:off x="4005072" y="1572768"/>
-            <a:ext cx="329184" cy="329184"/>
+            <a:off x="6309360" y="1691640"/>
+            <a:ext cx="420624" cy="420624"/>
           </a:xfrm>
           <a:prstGeom prst="rect">
             <a:avLst/>
@@ -4221,35 +4185,71 @@
       </p:pic>
       <p:sp>
         <p:nvSpPr>
+          <p:cNvPr id="18" name="Text 13"/>
+          <p:cNvSpPr txBox="1"/>
+          <p:nvPr/>
+        </p:nvSpPr>
+        <p:spPr>
+          <a:xfrm>
+            <a:off x="6309360" y="2377440"/>
+            <a:ext cx="2194560" cy="411480"/>
+          </a:xfrm>
+          <a:prstGeom prst="rect">
+            <a:avLst/>
+          </a:prstGeom>
+          <a:noFill/>
+          <a:ln/>
+        </p:spPr>
+        <p:txBody>
+          <a:bodyPr wrap="square" lIns="0" tIns="0" rIns="0" bIns="0" rtlCol="0" anchor="ctr"/>
+          <a:lstStyle/>
+          <a:p>
+            <a:pPr indent="0" marL="0">
+              <a:buNone/>
+            </a:pPr>
+            <a:r>
+              <a:rPr lang="en-US" sz="2200" b="1" dirty="0">
+                <a:solidFill>
+                  <a:srgbClr val="FFFFFF"/>
+                </a:solidFill>
+              </a:rPr>
+              <a:t>Approve</a:t>
+            </a:r>
+            <a:endParaRPr lang="en-US" sz="2200" dirty="0"/>
+          </a:p>
+        </p:txBody>
+      </p:sp>
+      <p:sp>
+        <p:nvSpPr>
           <p:cNvPr id="19" name="Text 14"/>
           <p:cNvSpPr txBox="1"/>
           <p:nvPr/>
         </p:nvSpPr>
         <p:spPr>
           <a:xfrm>
-            <a:off x="3959352" y="2121408"/>
-            <a:ext cx="1325880" cy="292608"/>
-          </a:xfrm>
-          <a:prstGeom prst="rect">
-            <a:avLst/>
-          </a:prstGeom>
-          <a:noFill/>
-          <a:ln/>
-        </p:spPr>
-        <p:txBody>
-          <a:bodyPr wrap="square" lIns="0" tIns="0" rIns="0" bIns="0" rtlCol="0" anchor="ctr"/>
-          <a:lstStyle/>
-          <a:p>
-            <a:pPr indent="0" marL="0">
-              <a:buNone/>
-            </a:pPr>
-            <a:r>
-              <a:rPr lang="en-US" sz="1250" b="1" dirty="0">
-                <a:solidFill>
-                  <a:srgbClr val="FFFFFF"/>
-                </a:solidFill>
-              </a:rPr>
-              <a:t>Agent prepares</a:t>
+            <a:off x="6309360" y="2816352"/>
+            <a:ext cx="2194560" cy="731520"/>
+          </a:xfrm>
+          <a:prstGeom prst="rect">
+            <a:avLst/>
+          </a:prstGeom>
+          <a:noFill/>
+          <a:ln/>
+        </p:spPr>
+        <p:txBody>
+          <a:bodyPr wrap="square" lIns="0" tIns="0" rIns="0" bIns="0" rtlCol="0" anchor="t"/>
+          <a:lstStyle/>
+          <a:p>
+            <a:pPr indent="0" marL="0">
+              <a:buNone/>
+            </a:pPr>
+            <a:r>
+              <a:rPr lang="en-US" sz="1250" dirty="0">
+                <a:solidFill>
+                  <a:srgbClr val="C9CBD3"/>
+                </a:solidFill>
+              </a:rPr>
+              <a:t>The one or two people who must sign, sign in one place. Then it deploys, fully logged.</a:t>
             </a:r>
             <a:endParaRPr lang="en-US" sz="1250" dirty="0"/>
           </a:p>
@@ -4257,94 +4257,22 @@
       </p:sp>
       <p:sp>
         <p:nvSpPr>
-          <p:cNvPr id="20" name="Text 15"/>
-          <p:cNvSpPr txBox="1"/>
-          <p:nvPr/>
-        </p:nvSpPr>
-        <p:spPr>
-          <a:xfrm>
-            <a:off x="3959352" y="2432304"/>
-            <a:ext cx="1325880" cy="1143000"/>
-          </a:xfrm>
-          <a:prstGeom prst="rect">
-            <a:avLst/>
-          </a:prstGeom>
-          <a:noFill/>
-          <a:ln/>
-        </p:spPr>
-        <p:txBody>
-          <a:bodyPr wrap="square" lIns="0" tIns="0" rIns="0" bIns="0" rtlCol="0" anchor="t"/>
-          <a:lstStyle/>
-          <a:p>
-            <a:pPr indent="0" marL="0">
-              <a:buNone/>
-            </a:pPr>
-            <a:r>
-              <a:rPr lang="en-US" sz="1000" dirty="0">
-                <a:solidFill>
-                  <a:srgbClr val="C9CBD3"/>
-                </a:solidFill>
-              </a:rPr>
-              <a:t>An Azure AI Foundry agent drafts the Bicep and a risk memo. Read-only; it never approves.</a:t>
-            </a:r>
-            <a:endParaRPr lang="en-US" sz="1000" dirty="0"/>
-          </a:p>
-        </p:txBody>
-      </p:sp>
-      <p:sp>
-        <p:nvSpPr>
-          <p:cNvPr id="21" name="Text 16"/>
-          <p:cNvSpPr txBox="1"/>
-          <p:nvPr/>
-        </p:nvSpPr>
-        <p:spPr>
-          <a:xfrm>
-            <a:off x="5340096" y="2240280"/>
-            <a:ext cx="228600" cy="365760"/>
-          </a:xfrm>
-          <a:prstGeom prst="rect">
-            <a:avLst/>
-          </a:prstGeom>
-          <a:noFill/>
-          <a:ln/>
-        </p:spPr>
-        <p:txBody>
-          <a:bodyPr wrap="square" lIns="0" tIns="0" rIns="0" bIns="0" rtlCol="0" anchor="ctr"/>
-          <a:lstStyle/>
-          <a:p>
-            <a:pPr algn="ctr" indent="0" marL="0">
-              <a:buNone/>
-            </a:pPr>
-            <a:r>
-              <a:rPr lang="en-US" sz="2200" dirty="0">
-                <a:solidFill>
-                  <a:srgbClr val="F79E1B"/>
-                </a:solidFill>
-              </a:rPr>
-              <a:t>›</a:t>
-            </a:r>
-            <a:endParaRPr lang="en-US" sz="2200" dirty="0"/>
-          </a:p>
-        </p:txBody>
-      </p:sp>
-      <p:sp>
-        <p:nvSpPr>
-          <p:cNvPr id="22" name="Shape 17"/>
+          <p:cNvPr id="20" name="Shape 15"/>
           <p:cNvSpPr/>
           <p:nvPr/>
         </p:nvSpPr>
         <p:spPr>
           <a:xfrm>
-            <a:off x="5504688" y="1371600"/>
-            <a:ext cx="1554480" cy="2240280"/>
+            <a:off x="457200" y="3794760"/>
+            <a:ext cx="4069080" cy="822960"/>
           </a:xfrm>
           <a:prstGeom prst="roundRect">
             <a:avLst>
-              <a:gd name="adj" fmla="val 8235"/>
+              <a:gd name="adj" fmla="val 15556"/>
             </a:avLst>
           </a:prstGeom>
           <a:solidFill>
-            <a:srgbClr val="1A1A1E">
+            <a:srgbClr val="1F1414">
               <a:alpha val="88000"/>
             </a:srgbClr>
           </a:solidFill>
@@ -4358,179 +4286,22 @@
       </p:sp>
       <p:sp>
         <p:nvSpPr>
-          <p:cNvPr id="23" name="Shape 18"/>
+          <p:cNvPr id="21" name="Shape 16"/>
           <p:cNvSpPr/>
           <p:nvPr/>
         </p:nvSpPr>
         <p:spPr>
           <a:xfrm>
-            <a:off x="5586984" y="1472184"/>
-            <a:ext cx="530352" cy="530352"/>
-          </a:xfrm>
-          <a:prstGeom prst="ellipse">
-            <a:avLst/>
-          </a:prstGeom>
-          <a:solidFill>
-            <a:srgbClr val="26262C"/>
-          </a:solidFill>
-          <a:ln w="6350">
-            <a:solidFill>
-              <a:srgbClr val="34343B"/>
-            </a:solidFill>
-            <a:prstDash val="solid"/>
-          </a:ln>
-        </p:spPr>
-      </p:sp>
-      <p:pic>
-        <p:nvPicPr>
-          <p:cNvPr id="24" name="Image 3" descr="preencoded.png">    </p:cNvPr>
-          <p:cNvPicPr>
-            <a:picLocks noChangeAspect="1"/>
-          </p:cNvPicPr>
-          <p:nvPr/>
-        </p:nvPicPr>
-        <p:blipFill>
-          <a:blip r:embed="rId4"/>
-          <a:stretch>
-            <a:fillRect/>
-          </a:stretch>
-        </p:blipFill>
-        <p:spPr>
-          <a:xfrm>
-            <a:off x="5687568" y="1572768"/>
-            <a:ext cx="329184" cy="329184"/>
-          </a:xfrm>
-          <a:prstGeom prst="rect">
-            <a:avLst/>
-          </a:prstGeom>
-        </p:spPr>
-      </p:pic>
-      <p:sp>
-        <p:nvSpPr>
-          <p:cNvPr id="25" name="Text 19"/>
-          <p:cNvSpPr txBox="1"/>
-          <p:nvPr/>
-        </p:nvSpPr>
-        <p:spPr>
-          <a:xfrm>
-            <a:off x="5641848" y="2121408"/>
-            <a:ext cx="1325880" cy="292608"/>
-          </a:xfrm>
-          <a:prstGeom prst="rect">
-            <a:avLst/>
-          </a:prstGeom>
-          <a:noFill/>
-          <a:ln/>
-        </p:spPr>
-        <p:txBody>
-          <a:bodyPr wrap="square" lIns="0" tIns="0" rIns="0" bIns="0" rtlCol="0" anchor="ctr"/>
-          <a:lstStyle/>
-          <a:p>
-            <a:pPr indent="0" marL="0">
-              <a:buNone/>
-            </a:pPr>
-            <a:r>
-              <a:rPr lang="en-US" sz="1250" b="1" dirty="0">
-                <a:solidFill>
-                  <a:srgbClr val="FFFFFF"/>
-                </a:solidFill>
-              </a:rPr>
-              <a:t>People approve</a:t>
-            </a:r>
-            <a:endParaRPr lang="en-US" sz="1250" dirty="0"/>
-          </a:p>
-        </p:txBody>
-      </p:sp>
-      <p:sp>
-        <p:nvSpPr>
-          <p:cNvPr id="26" name="Text 20"/>
-          <p:cNvSpPr txBox="1"/>
-          <p:nvPr/>
-        </p:nvSpPr>
-        <p:spPr>
-          <a:xfrm>
-            <a:off x="5641848" y="2432304"/>
-            <a:ext cx="1325880" cy="1143000"/>
-          </a:xfrm>
-          <a:prstGeom prst="rect">
-            <a:avLst/>
-          </a:prstGeom>
-          <a:noFill/>
-          <a:ln/>
-        </p:spPr>
-        <p:txBody>
-          <a:bodyPr wrap="square" lIns="0" tIns="0" rIns="0" bIns="0" rtlCol="0" anchor="t"/>
-          <a:lstStyle/>
-          <a:p>
-            <a:pPr indent="0" marL="0">
-              <a:buNone/>
-            </a:pPr>
-            <a:r>
-              <a:rPr lang="en-US" sz="1000" dirty="0">
-                <a:solidFill>
-                  <a:srgbClr val="C9CBD3"/>
-                </a:solidFill>
-              </a:rPr>
-              <a:t>Only the approvals that must stay human, in parallel. A GitHub gate blocks deployment until they sign.</a:t>
-            </a:r>
-            <a:endParaRPr lang="en-US" sz="1000" dirty="0"/>
-          </a:p>
-        </p:txBody>
-      </p:sp>
-      <p:sp>
-        <p:nvSpPr>
-          <p:cNvPr id="27" name="Text 21"/>
-          <p:cNvSpPr txBox="1"/>
-          <p:nvPr/>
-        </p:nvSpPr>
-        <p:spPr>
-          <a:xfrm>
-            <a:off x="7022592" y="2240280"/>
-            <a:ext cx="228600" cy="365760"/>
-          </a:xfrm>
-          <a:prstGeom prst="rect">
-            <a:avLst/>
-          </a:prstGeom>
-          <a:noFill/>
-          <a:ln/>
-        </p:spPr>
-        <p:txBody>
-          <a:bodyPr wrap="square" lIns="0" tIns="0" rIns="0" bIns="0" rtlCol="0" anchor="ctr"/>
-          <a:lstStyle/>
-          <a:p>
-            <a:pPr algn="ctr" indent="0" marL="0">
-              <a:buNone/>
-            </a:pPr>
-            <a:r>
-              <a:rPr lang="en-US" sz="2200" dirty="0">
-                <a:solidFill>
-                  <a:srgbClr val="F79E1B"/>
-                </a:solidFill>
-              </a:rPr>
-              <a:t>›</a:t>
-            </a:r>
-            <a:endParaRPr lang="en-US" sz="2200" dirty="0"/>
-          </a:p>
-        </p:txBody>
-      </p:sp>
-      <p:sp>
-        <p:nvSpPr>
-          <p:cNvPr id="28" name="Shape 22"/>
-          <p:cNvSpPr/>
-          <p:nvPr/>
-        </p:nvSpPr>
-        <p:spPr>
-          <a:xfrm>
-            <a:off x="7187184" y="1371600"/>
-            <a:ext cx="1554480" cy="2240280"/>
+            <a:off x="4617720" y="3794760"/>
+            <a:ext cx="4069080" cy="822960"/>
           </a:xfrm>
           <a:prstGeom prst="roundRect">
             <a:avLst>
-              <a:gd name="adj" fmla="val 8235"/>
+              <a:gd name="adj" fmla="val 15556"/>
             </a:avLst>
           </a:prstGeom>
           <a:solidFill>
-            <a:srgbClr val="1A1A1E">
+            <a:srgbClr val="12201A">
               <a:alpha val="88000"/>
             </a:srgbClr>
           </a:solidFill>
@@ -4544,63 +4315,14 @@
       </p:sp>
       <p:sp>
         <p:nvSpPr>
-          <p:cNvPr id="29" name="Shape 23"/>
-          <p:cNvSpPr/>
-          <p:nvPr/>
-        </p:nvSpPr>
-        <p:spPr>
-          <a:xfrm>
-            <a:off x="7269480" y="1472184"/>
-            <a:ext cx="530352" cy="530352"/>
-          </a:xfrm>
-          <a:prstGeom prst="ellipse">
-            <a:avLst/>
-          </a:prstGeom>
-          <a:solidFill>
-            <a:srgbClr val="26262C"/>
-          </a:solidFill>
-          <a:ln w="6350">
-            <a:solidFill>
-              <a:srgbClr val="34343B"/>
-            </a:solidFill>
-            <a:prstDash val="solid"/>
-          </a:ln>
-        </p:spPr>
-      </p:sp>
-      <p:pic>
-        <p:nvPicPr>
-          <p:cNvPr id="30" name="Image 4" descr="preencoded.png">    </p:cNvPr>
-          <p:cNvPicPr>
-            <a:picLocks noChangeAspect="1"/>
-          </p:cNvPicPr>
-          <p:nvPr/>
-        </p:nvPicPr>
-        <p:blipFill>
-          <a:blip r:embed="rId5"/>
-          <a:stretch>
-            <a:fillRect/>
-          </a:stretch>
-        </p:blipFill>
-        <p:spPr>
-          <a:xfrm>
-            <a:off x="7370064" y="1572768"/>
-            <a:ext cx="329184" cy="329184"/>
-          </a:xfrm>
-          <a:prstGeom prst="rect">
-            <a:avLst/>
-          </a:prstGeom>
-        </p:spPr>
-      </p:pic>
-      <p:sp>
-        <p:nvSpPr>
-          <p:cNvPr id="31" name="Text 24"/>
-          <p:cNvSpPr txBox="1"/>
-          <p:nvPr/>
-        </p:nvSpPr>
-        <p:spPr>
-          <a:xfrm>
-            <a:off x="7324344" y="2121408"/>
-            <a:ext cx="1325880" cy="292608"/>
+          <p:cNvPr id="22" name="Text 17"/>
+          <p:cNvSpPr txBox="1"/>
+          <p:nvPr/>
+        </p:nvSpPr>
+        <p:spPr>
+          <a:xfrm>
+            <a:off x="685800" y="3858768"/>
+            <a:ext cx="1828800" cy="228600"/>
           </a:xfrm>
           <a:prstGeom prst="rect">
             <a:avLst/>
@@ -4616,48 +4338,84 @@
               <a:buNone/>
             </a:pPr>
             <a:r>
-              <a:rPr lang="en-US" sz="1250" b="1" dirty="0">
+              <a:rPr lang="en-US" sz="1000" b="1" dirty="0">
+                <a:solidFill>
+                  <a:srgbClr val="EB001B"/>
+                </a:solidFill>
+              </a:rPr>
+              <a:t>Today</a:t>
+            </a:r>
+            <a:endParaRPr lang="en-US" sz="1000" dirty="0"/>
+          </a:p>
+        </p:txBody>
+      </p:sp>
+      <p:sp>
+        <p:nvSpPr>
+          <p:cNvPr id="23" name="Text 18"/>
+          <p:cNvSpPr txBox="1"/>
+          <p:nvPr/>
+        </p:nvSpPr>
+        <p:spPr>
+          <a:xfrm>
+            <a:off x="685800" y="4096512"/>
+            <a:ext cx="3657600" cy="411480"/>
+          </a:xfrm>
+          <a:prstGeom prst="rect">
+            <a:avLst/>
+          </a:prstGeom>
+          <a:noFill/>
+          <a:ln/>
+        </p:spPr>
+        <p:txBody>
+          <a:bodyPr wrap="square" lIns="0" tIns="0" rIns="0" bIns="0" rtlCol="0" anchor="ctr"/>
+          <a:lstStyle/>
+          <a:p>
+            <a:pPr indent="0" marL="0">
+              <a:buNone/>
+            </a:pPr>
+            <a:r>
+              <a:rPr lang="en-US" sz="1800" b="1" dirty="0">
                 <a:solidFill>
                   <a:srgbClr val="FFFFFF"/>
                 </a:solidFill>
               </a:rPr>
-              <a:t>Evidence written</a:t>
-            </a:r>
-            <a:endParaRPr lang="en-US" sz="1250" dirty="0"/>
-          </a:p>
-        </p:txBody>
-      </p:sp>
-      <p:sp>
-        <p:nvSpPr>
-          <p:cNvPr id="32" name="Text 25"/>
-          <p:cNvSpPr txBox="1"/>
-          <p:nvPr/>
-        </p:nvSpPr>
-        <p:spPr>
-          <a:xfrm>
-            <a:off x="7324344" y="2432304"/>
-            <a:ext cx="1325880" cy="1143000"/>
-          </a:xfrm>
-          <a:prstGeom prst="rect">
-            <a:avLst/>
-          </a:prstGeom>
-          <a:noFill/>
-          <a:ln/>
-        </p:spPr>
-        <p:txBody>
-          <a:bodyPr wrap="square" lIns="0" tIns="0" rIns="0" bIns="0" rtlCol="0" anchor="t"/>
-          <a:lstStyle/>
-          <a:p>
-            <a:pPr indent="0" marL="0">
-              <a:buNone/>
-            </a:pPr>
-            <a:r>
-              <a:rPr lang="en-US" sz="1000" dirty="0">
-                <a:solidFill>
-                  <a:srgbClr val="C9CBD3"/>
-                </a:solidFill>
-              </a:rPr>
-              <a:t>Append-only audit trail. The pack a partner bank or auditor asks for already exists.</a:t>
+              <a:t>12 handoffs, 6 to 8 months</a:t>
+            </a:r>
+            <a:endParaRPr lang="en-US" sz="1800" dirty="0"/>
+          </a:p>
+        </p:txBody>
+      </p:sp>
+      <p:sp>
+        <p:nvSpPr>
+          <p:cNvPr id="24" name="Text 19"/>
+          <p:cNvSpPr txBox="1"/>
+          <p:nvPr/>
+        </p:nvSpPr>
+        <p:spPr>
+          <a:xfrm>
+            <a:off x="4846320" y="3858768"/>
+            <a:ext cx="1828800" cy="228600"/>
+          </a:xfrm>
+          <a:prstGeom prst="rect">
+            <a:avLst/>
+          </a:prstGeom>
+          <a:noFill/>
+          <a:ln/>
+        </p:spPr>
+        <p:txBody>
+          <a:bodyPr wrap="square" lIns="0" tIns="0" rIns="0" bIns="0" rtlCol="0" anchor="ctr"/>
+          <a:lstStyle/>
+          <a:p>
+            <a:pPr indent="0" marL="0">
+              <a:buNone/>
+            </a:pPr>
+            <a:r>
+              <a:rPr lang="en-US" sz="1000" b="1" dirty="0">
+                <a:solidFill>
+                  <a:srgbClr val="2ED573"/>
+                </a:solidFill>
+              </a:rPr>
+              <a:t>With LaunchGate</a:t>
             </a:r>
             <a:endParaRPr lang="en-US" sz="1000" dirty="0"/>
           </a:p>
@@ -4665,101 +4423,14 @@
       </p:sp>
       <p:sp>
         <p:nvSpPr>
-          <p:cNvPr id="33" name="Shape 26"/>
-          <p:cNvSpPr/>
-          <p:nvPr/>
-        </p:nvSpPr>
-        <p:spPr>
-          <a:xfrm>
-            <a:off x="457200" y="3749040"/>
-            <a:ext cx="2651760" cy="868680"/>
-          </a:xfrm>
-          <a:prstGeom prst="roundRect">
-            <a:avLst>
-              <a:gd name="adj" fmla="val 14737"/>
-            </a:avLst>
-          </a:prstGeom>
-          <a:solidFill>
-            <a:srgbClr val="1F1414">
-              <a:alpha val="88000"/>
-            </a:srgbClr>
-          </a:solidFill>
-          <a:ln w="9525">
-            <a:solidFill>
-              <a:srgbClr val="2A2A30"/>
-            </a:solidFill>
-            <a:prstDash val="solid"/>
-          </a:ln>
-        </p:spPr>
-      </p:sp>
-      <p:sp>
-        <p:nvSpPr>
-          <p:cNvPr id="34" name="Shape 27"/>
-          <p:cNvSpPr/>
-          <p:nvPr/>
-        </p:nvSpPr>
-        <p:spPr>
-          <a:xfrm>
-            <a:off x="3246120" y="3749040"/>
-            <a:ext cx="2651760" cy="868680"/>
-          </a:xfrm>
-          <a:prstGeom prst="roundRect">
-            <a:avLst>
-              <a:gd name="adj" fmla="val 14737"/>
-            </a:avLst>
-          </a:prstGeom>
-          <a:solidFill>
-            <a:srgbClr val="12201A">
-              <a:alpha val="88000"/>
-            </a:srgbClr>
-          </a:solidFill>
-          <a:ln w="9525">
-            <a:solidFill>
-              <a:srgbClr val="2A2A30"/>
-            </a:solidFill>
-            <a:prstDash val="solid"/>
-          </a:ln>
-        </p:spPr>
-      </p:sp>
-      <p:sp>
-        <p:nvSpPr>
-          <p:cNvPr id="35" name="Shape 28"/>
-          <p:cNvSpPr/>
-          <p:nvPr/>
-        </p:nvSpPr>
-        <p:spPr>
-          <a:xfrm>
-            <a:off x="6035040" y="3749040"/>
-            <a:ext cx="2651760" cy="868680"/>
-          </a:xfrm>
-          <a:prstGeom prst="roundRect">
-            <a:avLst>
-              <a:gd name="adj" fmla="val 14737"/>
-            </a:avLst>
-          </a:prstGeom>
-          <a:solidFill>
-            <a:srgbClr val="1A1A1E">
-              <a:alpha val="88000"/>
-            </a:srgbClr>
-          </a:solidFill>
-          <a:ln w="9525">
-            <a:solidFill>
-              <a:srgbClr val="2A2A30"/>
-            </a:solidFill>
-            <a:prstDash val="solid"/>
-          </a:ln>
-        </p:spPr>
-      </p:sp>
-      <p:sp>
-        <p:nvSpPr>
-          <p:cNvPr id="36" name="Text 29"/>
-          <p:cNvSpPr txBox="1"/>
-          <p:nvPr/>
-        </p:nvSpPr>
-        <p:spPr>
-          <a:xfrm>
-            <a:off x="640080" y="3803904"/>
-            <a:ext cx="2286000" cy="228600"/>
+          <p:cNvPr id="25" name="Text 20"/>
+          <p:cNvSpPr txBox="1"/>
+          <p:nvPr/>
+        </p:nvSpPr>
+        <p:spPr>
+          <a:xfrm>
+            <a:off x="4846320" y="4096512"/>
+            <a:ext cx="3657600" cy="411480"/>
           </a:xfrm>
           <a:prstGeom prst="rect">
             <a:avLst/>
@@ -4775,194 +4446,14 @@
               <a:buNone/>
             </a:pPr>
             <a:r>
-              <a:rPr lang="en-US" sz="1000" b="1" dirty="0">
-                <a:solidFill>
-                  <a:srgbClr val="EB001B"/>
-                </a:solidFill>
-              </a:rPr>
-              <a:t>Today</a:t>
-            </a:r>
-            <a:endParaRPr lang="en-US" sz="1000" dirty="0"/>
-          </a:p>
-        </p:txBody>
-      </p:sp>
-      <p:sp>
-        <p:nvSpPr>
-          <p:cNvPr id="37" name="Text 30"/>
-          <p:cNvSpPr txBox="1"/>
-          <p:nvPr/>
-        </p:nvSpPr>
-        <p:spPr>
-          <a:xfrm>
-            <a:off x="640080" y="4041648"/>
-            <a:ext cx="2377440" cy="457200"/>
-          </a:xfrm>
-          <a:prstGeom prst="rect">
-            <a:avLst/>
-          </a:prstGeom>
-          <a:noFill/>
-          <a:ln/>
-        </p:spPr>
-        <p:txBody>
-          <a:bodyPr wrap="square" lIns="0" tIns="0" rIns="0" bIns="0" rtlCol="0" anchor="ctr"/>
-          <a:lstStyle/>
-          <a:p>
-            <a:pPr indent="0" marL="0">
-              <a:buNone/>
-            </a:pPr>
-            <a:r>
-              <a:rPr lang="en-US" sz="1400" b="1" dirty="0">
+              <a:rPr lang="en-US" sz="1800" b="1" dirty="0">
                 <a:solidFill>
                   <a:srgbClr val="FFFFFF"/>
                 </a:solidFill>
               </a:rPr>
-              <a:t>12 handoffs, 6 to 8 months</a:t>
-            </a:r>
-            <a:endParaRPr lang="en-US" sz="1400" dirty="0"/>
-          </a:p>
-        </p:txBody>
-      </p:sp>
-      <p:sp>
-        <p:nvSpPr>
-          <p:cNvPr id="38" name="Text 31"/>
-          <p:cNvSpPr txBox="1"/>
-          <p:nvPr/>
-        </p:nvSpPr>
-        <p:spPr>
-          <a:xfrm>
-            <a:off x="3429000" y="3803904"/>
-            <a:ext cx="2286000" cy="228600"/>
-          </a:xfrm>
-          <a:prstGeom prst="rect">
-            <a:avLst/>
-          </a:prstGeom>
-          <a:noFill/>
-          <a:ln/>
-        </p:spPr>
-        <p:txBody>
-          <a:bodyPr wrap="square" lIns="0" tIns="0" rIns="0" bIns="0" rtlCol="0" anchor="ctr"/>
-          <a:lstStyle/>
-          <a:p>
-            <a:pPr indent="0" marL="0">
-              <a:buNone/>
-            </a:pPr>
-            <a:r>
-              <a:rPr lang="en-US" sz="1000" b="1" dirty="0">
-                <a:solidFill>
-                  <a:srgbClr val="2ED573"/>
-                </a:solidFill>
-              </a:rPr>
-              <a:t>With LaunchGate</a:t>
-            </a:r>
-            <a:endParaRPr lang="en-US" sz="1000" dirty="0"/>
-          </a:p>
-        </p:txBody>
-      </p:sp>
-      <p:sp>
-        <p:nvSpPr>
-          <p:cNvPr id="39" name="Text 32"/>
-          <p:cNvSpPr txBox="1"/>
-          <p:nvPr/>
-        </p:nvSpPr>
-        <p:spPr>
-          <a:xfrm>
-            <a:off x="3429000" y="4041648"/>
-            <a:ext cx="2377440" cy="457200"/>
-          </a:xfrm>
-          <a:prstGeom prst="rect">
-            <a:avLst/>
-          </a:prstGeom>
-          <a:noFill/>
-          <a:ln/>
-        </p:spPr>
-        <p:txBody>
-          <a:bodyPr wrap="square" lIns="0" tIns="0" rIns="0" bIns="0" rtlCol="0" anchor="ctr"/>
-          <a:lstStyle/>
-          <a:p>
-            <a:pPr indent="0" marL="0">
-              <a:buNone/>
-            </a:pPr>
-            <a:r>
-              <a:rPr lang="en-US" sz="1400" b="1" dirty="0">
-                <a:solidFill>
-                  <a:srgbClr val="FFFFFF"/>
-                </a:solidFill>
-              </a:rPr>
-              <a:t>1 request + 1 to 2 human approvals</a:t>
-            </a:r>
-            <a:endParaRPr lang="en-US" sz="1400" dirty="0"/>
-          </a:p>
-        </p:txBody>
-      </p:sp>
-      <p:sp>
-        <p:nvSpPr>
-          <p:cNvPr id="40" name="Text 33"/>
-          <p:cNvSpPr txBox="1"/>
-          <p:nvPr/>
-        </p:nvSpPr>
-        <p:spPr>
-          <a:xfrm>
-            <a:off x="6217920" y="3803904"/>
-            <a:ext cx="2286000" cy="228600"/>
-          </a:xfrm>
-          <a:prstGeom prst="rect">
-            <a:avLst/>
-          </a:prstGeom>
-          <a:noFill/>
-          <a:ln/>
-        </p:spPr>
-        <p:txBody>
-          <a:bodyPr wrap="square" lIns="0" tIns="0" rIns="0" bIns="0" rtlCol="0" anchor="ctr"/>
-          <a:lstStyle/>
-          <a:p>
-            <a:pPr indent="0" marL="0">
-              <a:buNone/>
-            </a:pPr>
-            <a:r>
-              <a:rPr lang="en-US" sz="1000" b="1" dirty="0">
-                <a:solidFill>
-                  <a:srgbClr val="F79E1B"/>
-                </a:solidFill>
-              </a:rPr>
-              <a:t>What never changes</a:t>
-            </a:r>
-            <a:endParaRPr lang="en-US" sz="1000" dirty="0"/>
-          </a:p>
-        </p:txBody>
-      </p:sp>
-      <p:sp>
-        <p:nvSpPr>
-          <p:cNvPr id="41" name="Text 34"/>
-          <p:cNvSpPr txBox="1"/>
-          <p:nvPr/>
-        </p:nvSpPr>
-        <p:spPr>
-          <a:xfrm>
-            <a:off x="6217920" y="4041648"/>
-            <a:ext cx="2377440" cy="457200"/>
-          </a:xfrm>
-          <a:prstGeom prst="rect">
-            <a:avLst/>
-          </a:prstGeom>
-          <a:noFill/>
-          <a:ln/>
-        </p:spPr>
-        <p:txBody>
-          <a:bodyPr wrap="square" lIns="0" tIns="0" rIns="0" bIns="0" rtlCol="0" anchor="ctr"/>
-          <a:lstStyle/>
-          <a:p>
-            <a:pPr indent="0" marL="0">
-              <a:buNone/>
-            </a:pPr>
-            <a:r>
-              <a:rPr lang="en-US" sz="1400" b="1" dirty="0">
-                <a:solidFill>
-                  <a:srgbClr val="FFFFFF"/>
-                </a:solidFill>
-              </a:rPr>
-              <a:t>Nothing deploys without a person</a:t>
-            </a:r>
-            <a:endParaRPr lang="en-US" sz="1400" dirty="0"/>
+              <a:t>1 request, 1 to 2 approvals, days</a:t>
+            </a:r>
+            <a:endParaRPr lang="en-US" sz="1800" dirty="0"/>
           </a:p>
         </p:txBody>
       </p:sp>

</xml_diff>